<commit_message>
Complete final submission artifact bundle
Captures the final report, presentation, demo checklist, and individual reflection outputs as repository-native submission evidence.

Constraint: Course submission artifacts live under docs/final-submission and include generated Office/PDF/image files.

Rejected: Leaving regenerated submission files untracked | The user asked to commit and push the completed work, and partial artifacts were already published in the prior commit.

Confidence: high

Scope-risk: narrow

Directive: Treat docs/final-submission as generated release/submission evidence; refresh manifest byte sizes when regenerating artifacts.

Tested: git diff --check -- docs/final-submission

Not-tested: Visual rerender of the regenerated Office/PDF files after this final artifact-only commit.
</commit_message>
<xml_diff>
--- a/docs/final-submission/Time_Table_Final_Presentation_32183022.pptx
+++ b/docs/final-submission/Time_Table_Final_Presentation_32183022.pptx
@@ -7163,8 +7163,8 @@
         </p:nvSpPr>
         <p:spPr>
           <a:xfrm>
-            <a:off x="6720840" y="2240280"/>
-            <a:ext cx="3886200" cy="1143000"/>
+            <a:off x="6720840" y="2148840"/>
+            <a:ext cx="3886200" cy="1600200"/>
           </a:xfrm>
           <a:prstGeom prst="rect">
             <a:avLst/>
@@ -7181,7 +7181,7 @@
               <a:lnSpc>
                 <a:spcPct val="106000"/>
               </a:lnSpc>
-              <a:defRPr sz="1600" b="1">
+              <a:defRPr sz="1350" b="1">
                 <a:solidFill>
                   <a:srgbClr val="111827"/>
                 </a:solidFill>
@@ -7189,6 +7189,51 @@
               </a:defRPr>
             </a:pPr>
             <a:r>
+              <a:t>배포 링크</a:t>
+            </a:r>
+          </a:p>
+          <a:p>
+            <a:pPr>
+              <a:lnSpc>
+                <a:spcPct val="106000"/>
+              </a:lnSpc>
+              <a:defRPr sz="1350" b="1">
+                <a:solidFill>
+                  <a:srgbClr val="111827"/>
+                </a:solidFill>
+                <a:latin typeface="맑은 고딕"/>
+              </a:defRPr>
+            </a:pPr>
+            <a:r>
+              <a:t>https://timetable-608682434352.asia-northeast2.run.app/</a:t>
+            </a:r>
+          </a:p>
+          <a:p>
+            <a:pPr>
+              <a:lnSpc>
+                <a:spcPct val="106000"/>
+              </a:lnSpc>
+              <a:defRPr sz="1350" b="1">
+                <a:solidFill>
+                  <a:srgbClr val="111827"/>
+                </a:solidFill>
+                <a:latin typeface="맑은 고딕"/>
+              </a:defRPr>
+            </a:pPr>
+          </a:p>
+          <a:p>
+            <a:pPr>
+              <a:lnSpc>
+                <a:spcPct val="106000"/>
+              </a:lnSpc>
+              <a:defRPr sz="1350" b="1">
+                <a:solidFill>
+                  <a:srgbClr val="111827"/>
+                </a:solidFill>
+                <a:latin typeface="맑은 고딕"/>
+              </a:defRPr>
+            </a:pPr>
+            <a:r>
               <a:t>PPT 제출</a:t>
             </a:r>
           </a:p>
@@ -7197,7 +7242,7 @@
               <a:lnSpc>
                 <a:spcPct val="106000"/>
               </a:lnSpc>
-              <a:defRPr sz="1600" b="1">
+              <a:defRPr sz="1350" b="1">
                 <a:solidFill>
                   <a:srgbClr val="111827"/>
                 </a:solidFill>
@@ -7213,7 +7258,7 @@
               <a:lnSpc>
                 <a:spcPct val="106000"/>
               </a:lnSpc>
-              <a:defRPr sz="1600" b="1">
+              <a:defRPr sz="1350" b="1">
                 <a:solidFill>
                   <a:srgbClr val="111827"/>
                 </a:solidFill>
@@ -7229,7 +7274,7 @@
               <a:lnSpc>
                 <a:spcPct val="106000"/>
               </a:lnSpc>
-              <a:defRPr sz="1600" b="1">
+              <a:defRPr sz="1350" b="1">
                 <a:solidFill>
                   <a:srgbClr val="111827"/>
                 </a:solidFill>

</xml_diff>